<commit_message>
rr-test harness looking good. before state machine.
looking good. trails making a phase disk. orbit controls working.
</commit_message>
<xml_diff>
--- a/docs/figures/new diagrams 3.pptx
+++ b/docs/figures/new diagrams 3.pptx
@@ -353,7 +353,7 @@
           <a:p>
             <a:fld id="{783195BA-A24A-42A8-94D4-15E9273B559F}" type="datetimeFigureOut">
               <a:rPr lang="en-AU" smtClean="0"/>
-              <a:t>16/06/2026</a:t>
+              <a:t>3/07/2026</a:t>
             </a:fld>
             <a:endParaRPr lang="en-AU"/>
           </a:p>
@@ -553,7 +553,7 @@
           <a:p>
             <a:fld id="{783195BA-A24A-42A8-94D4-15E9273B559F}" type="datetimeFigureOut">
               <a:rPr lang="en-AU" smtClean="0"/>
-              <a:t>16/06/2026</a:t>
+              <a:t>3/07/2026</a:t>
             </a:fld>
             <a:endParaRPr lang="en-AU"/>
           </a:p>
@@ -763,7 +763,7 @@
           <a:p>
             <a:fld id="{783195BA-A24A-42A8-94D4-15E9273B559F}" type="datetimeFigureOut">
               <a:rPr lang="en-AU" smtClean="0"/>
-              <a:t>16/06/2026</a:t>
+              <a:t>3/07/2026</a:t>
             </a:fld>
             <a:endParaRPr lang="en-AU"/>
           </a:p>
@@ -963,7 +963,7 @@
           <a:p>
             <a:fld id="{783195BA-A24A-42A8-94D4-15E9273B559F}" type="datetimeFigureOut">
               <a:rPr lang="en-AU" smtClean="0"/>
-              <a:t>16/06/2026</a:t>
+              <a:t>3/07/2026</a:t>
             </a:fld>
             <a:endParaRPr lang="en-AU"/>
           </a:p>
@@ -1239,7 +1239,7 @@
           <a:p>
             <a:fld id="{783195BA-A24A-42A8-94D4-15E9273B559F}" type="datetimeFigureOut">
               <a:rPr lang="en-AU" smtClean="0"/>
-              <a:t>16/06/2026</a:t>
+              <a:t>3/07/2026</a:t>
             </a:fld>
             <a:endParaRPr lang="en-AU"/>
           </a:p>
@@ -1507,7 +1507,7 @@
           <a:p>
             <a:fld id="{783195BA-A24A-42A8-94D4-15E9273B559F}" type="datetimeFigureOut">
               <a:rPr lang="en-AU" smtClean="0"/>
-              <a:t>16/06/2026</a:t>
+              <a:t>3/07/2026</a:t>
             </a:fld>
             <a:endParaRPr lang="en-AU"/>
           </a:p>
@@ -1922,7 +1922,7 @@
           <a:p>
             <a:fld id="{783195BA-A24A-42A8-94D4-15E9273B559F}" type="datetimeFigureOut">
               <a:rPr lang="en-AU" smtClean="0"/>
-              <a:t>16/06/2026</a:t>
+              <a:t>3/07/2026</a:t>
             </a:fld>
             <a:endParaRPr lang="en-AU"/>
           </a:p>
@@ -2064,7 +2064,7 @@
           <a:p>
             <a:fld id="{783195BA-A24A-42A8-94D4-15E9273B559F}" type="datetimeFigureOut">
               <a:rPr lang="en-AU" smtClean="0"/>
-              <a:t>16/06/2026</a:t>
+              <a:t>3/07/2026</a:t>
             </a:fld>
             <a:endParaRPr lang="en-AU"/>
           </a:p>
@@ -2177,7 +2177,7 @@
           <a:p>
             <a:fld id="{783195BA-A24A-42A8-94D4-15E9273B559F}" type="datetimeFigureOut">
               <a:rPr lang="en-AU" smtClean="0"/>
-              <a:t>16/06/2026</a:t>
+              <a:t>3/07/2026</a:t>
             </a:fld>
             <a:endParaRPr lang="en-AU"/>
           </a:p>
@@ -2490,7 +2490,7 @@
           <a:p>
             <a:fld id="{783195BA-A24A-42A8-94D4-15E9273B559F}" type="datetimeFigureOut">
               <a:rPr lang="en-AU" smtClean="0"/>
-              <a:t>16/06/2026</a:t>
+              <a:t>3/07/2026</a:t>
             </a:fld>
             <a:endParaRPr lang="en-AU"/>
           </a:p>
@@ -2779,7 +2779,7 @@
           <a:p>
             <a:fld id="{783195BA-A24A-42A8-94D4-15E9273B559F}" type="datetimeFigureOut">
               <a:rPr lang="en-AU" smtClean="0"/>
-              <a:t>16/06/2026</a:t>
+              <a:t>3/07/2026</a:t>
             </a:fld>
             <a:endParaRPr lang="en-AU"/>
           </a:p>
@@ -3022,7 +3022,7 @@
           <a:p>
             <a:fld id="{783195BA-A24A-42A8-94D4-15E9273B559F}" type="datetimeFigureOut">
               <a:rPr lang="en-AU" smtClean="0"/>
-              <a:t>16/06/2026</a:t>
+              <a:t>3/07/2026</a:t>
             </a:fld>
             <a:endParaRPr lang="en-AU"/>
           </a:p>
@@ -15449,6 +15449,191 @@
           </p:style>
         </p:cxnSp>
       </p:grpSp>
+      <p:pic>
+        <p:nvPicPr>
+          <p:cNvPr id="21" name="Picture 20">
+            <a:extLst>
+              <a:ext uri="{FF2B5EF4-FFF2-40B4-BE49-F238E27FC236}">
+                <a16:creationId xmlns:a16="http://schemas.microsoft.com/office/drawing/2014/main" id="{CC4924C8-FD47-41D8-81E2-1443BB514B8E}"/>
+              </a:ext>
+            </a:extLst>
+          </p:cNvPr>
+          <p:cNvPicPr>
+            <a:picLocks noChangeAspect="1"/>
+          </p:cNvPicPr>
+          <p:nvPr/>
+        </p:nvPicPr>
+        <p:blipFill>
+          <a:blip r:embed="rId3"/>
+          <a:srcRect r="330" b="231"/>
+          <a:stretch>
+            <a:fillRect/>
+          </a:stretch>
+        </p:blipFill>
+        <p:spPr>
+          <a:xfrm rot="2675376">
+            <a:off x="9252857" y="2136814"/>
+            <a:ext cx="2892386" cy="2889169"/>
+          </a:xfrm>
+          <a:custGeom>
+            <a:avLst/>
+            <a:gdLst>
+              <a:gd name="connsiteX0" fmla="*/ 1446193 w 2892386"/>
+              <a:gd name="connsiteY0" fmla="*/ 266064 h 2889169"/>
+              <a:gd name="connsiteX1" fmla="*/ 269281 w 2892386"/>
+              <a:gd name="connsiteY1" fmla="*/ 1442976 h 2889169"/>
+              <a:gd name="connsiteX2" fmla="*/ 1446193 w 2892386"/>
+              <a:gd name="connsiteY2" fmla="*/ 2619888 h 2889169"/>
+              <a:gd name="connsiteX3" fmla="*/ 2623105 w 2892386"/>
+              <a:gd name="connsiteY3" fmla="*/ 1442976 h 2889169"/>
+              <a:gd name="connsiteX4" fmla="*/ 1446193 w 2892386"/>
+              <a:gd name="connsiteY4" fmla="*/ 266064 h 2889169"/>
+              <a:gd name="connsiteX5" fmla="*/ 1382485 w 2892386"/>
+              <a:gd name="connsiteY5" fmla="*/ 0 h 2889169"/>
+              <a:gd name="connsiteX6" fmla="*/ 1509901 w 2892386"/>
+              <a:gd name="connsiteY6" fmla="*/ 0 h 2889169"/>
+              <a:gd name="connsiteX7" fmla="*/ 1594058 w 2892386"/>
+              <a:gd name="connsiteY7" fmla="*/ 4250 h 2889169"/>
+              <a:gd name="connsiteX8" fmla="*/ 2892386 w 2892386"/>
+              <a:gd name="connsiteY8" fmla="*/ 1442976 h 2889169"/>
+              <a:gd name="connsiteX9" fmla="*/ 1446193 w 2892386"/>
+              <a:gd name="connsiteY9" fmla="*/ 2889169 h 2889169"/>
+              <a:gd name="connsiteX10" fmla="*/ 0 w 2892386"/>
+              <a:gd name="connsiteY10" fmla="*/ 1442976 h 2889169"/>
+              <a:gd name="connsiteX11" fmla="*/ 1298328 w 2892386"/>
+              <a:gd name="connsiteY11" fmla="*/ 4250 h 2889169"/>
+            </a:gdLst>
+            <a:ahLst/>
+            <a:cxnLst>
+              <a:cxn ang="0">
+                <a:pos x="connsiteX0" y="connsiteY0"/>
+              </a:cxn>
+              <a:cxn ang="0">
+                <a:pos x="connsiteX1" y="connsiteY1"/>
+              </a:cxn>
+              <a:cxn ang="0">
+                <a:pos x="connsiteX2" y="connsiteY2"/>
+              </a:cxn>
+              <a:cxn ang="0">
+                <a:pos x="connsiteX3" y="connsiteY3"/>
+              </a:cxn>
+              <a:cxn ang="0">
+                <a:pos x="connsiteX4" y="connsiteY4"/>
+              </a:cxn>
+              <a:cxn ang="0">
+                <a:pos x="connsiteX5" y="connsiteY5"/>
+              </a:cxn>
+              <a:cxn ang="0">
+                <a:pos x="connsiteX6" y="connsiteY6"/>
+              </a:cxn>
+              <a:cxn ang="0">
+                <a:pos x="connsiteX7" y="connsiteY7"/>
+              </a:cxn>
+              <a:cxn ang="0">
+                <a:pos x="connsiteX8" y="connsiteY8"/>
+              </a:cxn>
+              <a:cxn ang="0">
+                <a:pos x="connsiteX9" y="connsiteY9"/>
+              </a:cxn>
+              <a:cxn ang="0">
+                <a:pos x="connsiteX10" y="connsiteY10"/>
+              </a:cxn>
+              <a:cxn ang="0">
+                <a:pos x="connsiteX11" y="connsiteY11"/>
+              </a:cxn>
+            </a:cxnLst>
+            <a:rect l="l" t="t" r="r" b="b"/>
+            <a:pathLst>
+              <a:path w="2892386" h="2889169">
+                <a:moveTo>
+                  <a:pt x="1446193" y="266064"/>
+                </a:moveTo>
+                <a:cubicBezTo>
+                  <a:pt x="796202" y="266064"/>
+                  <a:pt x="269281" y="792985"/>
+                  <a:pt x="269281" y="1442976"/>
+                </a:cubicBezTo>
+                <a:cubicBezTo>
+                  <a:pt x="269281" y="2092967"/>
+                  <a:pt x="796202" y="2619888"/>
+                  <a:pt x="1446193" y="2619888"/>
+                </a:cubicBezTo>
+                <a:cubicBezTo>
+                  <a:pt x="2096184" y="2619888"/>
+                  <a:pt x="2623105" y="2092967"/>
+                  <a:pt x="2623105" y="1442976"/>
+                </a:cubicBezTo>
+                <a:cubicBezTo>
+                  <a:pt x="2623105" y="792985"/>
+                  <a:pt x="2096184" y="266064"/>
+                  <a:pt x="1446193" y="266064"/>
+                </a:cubicBezTo>
+                <a:close/>
+                <a:moveTo>
+                  <a:pt x="1382485" y="0"/>
+                </a:moveTo>
+                <a:lnTo>
+                  <a:pt x="1509901" y="0"/>
+                </a:lnTo>
+                <a:lnTo>
+                  <a:pt x="1594058" y="4250"/>
+                </a:lnTo>
+                <a:cubicBezTo>
+                  <a:pt x="2323309" y="78309"/>
+                  <a:pt x="2892386" y="694186"/>
+                  <a:pt x="2892386" y="1442976"/>
+                </a:cubicBezTo>
+                <a:cubicBezTo>
+                  <a:pt x="2892386" y="2241686"/>
+                  <a:pt x="2244903" y="2889169"/>
+                  <a:pt x="1446193" y="2889169"/>
+                </a:cubicBezTo>
+                <a:cubicBezTo>
+                  <a:pt x="647483" y="2889169"/>
+                  <a:pt x="0" y="2241686"/>
+                  <a:pt x="0" y="1442976"/>
+                </a:cubicBezTo>
+                <a:cubicBezTo>
+                  <a:pt x="0" y="694186"/>
+                  <a:pt x="569077" y="78309"/>
+                  <a:pt x="1298328" y="4250"/>
+                </a:cubicBezTo>
+                <a:close/>
+              </a:path>
+            </a:pathLst>
+          </a:custGeom>
+        </p:spPr>
+      </p:pic>
+      <p:pic>
+        <p:nvPicPr>
+          <p:cNvPr id="7" name="Picture 6">
+            <a:extLst>
+              <a:ext uri="{FF2B5EF4-FFF2-40B4-BE49-F238E27FC236}">
+                <a16:creationId xmlns:a16="http://schemas.microsoft.com/office/drawing/2014/main" id="{AD77D2BA-9A2C-46D4-A199-E2915AB1FB7D}"/>
+              </a:ext>
+            </a:extLst>
+          </p:cNvPr>
+          <p:cNvPicPr>
+            <a:picLocks noChangeAspect="1"/>
+          </p:cNvPicPr>
+          <p:nvPr/>
+        </p:nvPicPr>
+        <p:blipFill>
+          <a:blip r:embed="rId4"/>
+          <a:stretch>
+            <a:fillRect/>
+          </a:stretch>
+        </p:blipFill>
+        <p:spPr>
+          <a:xfrm>
+            <a:off x="5776954" y="3628154"/>
+            <a:ext cx="2895851" cy="2895851"/>
+          </a:xfrm>
+          <a:prstGeom prst="rect">
+            <a:avLst/>
+          </a:prstGeom>
+        </p:spPr>
+      </p:pic>
     </p:spTree>
     <p:extLst>
       <p:ext uri="{BB962C8B-B14F-4D97-AF65-F5344CB8AC3E}">

</xml_diff>